<commit_message>
Apply full BRAND.md branding to pitch deck v3
Adds the signature brand motifs from BRAND.md that the deck was missing:
- shadow-ambient soft shadows on all cards/surfaces (flat elevation)
- always-visible "Blockchain Status: Secured" chip (mint dot + teal-ink
  on a muted surface) on content slides
- title-slide brand lockup (logo tile + "Krunchr / Compliance Engine")
  and a mint "Stellar-Secured Receipts" verified chip
- footer lockup with the "Compliance Engine" descriptor
- rounded-xl corner radius on cards

Co-Authored-By: Claude Sonnet 5 <noreply@anthropic.com>
Claude-Session: https://claude.ai/code/session_018Gpu5Yjdn1n74cf7wu8gXN
</commit_message>
<xml_diff>
--- a/docs/pitch-deck-v3.pptx
+++ b/docs/pitch-deck-v3.pptx
@@ -4313,8 +4313,8 @@
         </p:blipFill>
         <p:spPr>
           <a:xfrm>
-            <a:off x="731520" y="822960"/>
-            <a:ext cx="1005840" cy="1005840"/>
+            <a:off x="731520" y="777240"/>
+            <a:ext cx="868680" cy="868680"/>
           </a:xfrm>
           <a:prstGeom prst="rect">
             <a:avLst/>
@@ -4329,7 +4329,79 @@
         </p:nvSpPr>
         <p:spPr>
           <a:xfrm>
-            <a:off x="731520" y="2011680"/>
+            <a:off x="1783080" y="804672"/>
+            <a:ext cx="4572000" cy="411480"/>
+          </a:xfrm>
+          <a:prstGeom prst="rect">
+            <a:avLst/>
+          </a:prstGeom>
+          <a:noFill/>
+        </p:spPr>
+        <p:txBody>
+          <a:bodyPr wrap="square">
+            <a:spAutoFit/>
+          </a:bodyPr>
+          <a:lstStyle/>
+          <a:p>
+            <a:pPr algn="l">
+              <a:defRPr sz="3000" b="1">
+                <a:solidFill>
+                  <a:srgbClr val="0B1C30"/>
+                </a:solidFill>
+                <a:latin typeface="SF Pro Display"/>
+              </a:defRPr>
+            </a:pPr>
+            <a:r>
+              <a:t>Krunchr</a:t>
+            </a:r>
+          </a:p>
+        </p:txBody>
+      </p:sp>
+      <p:sp>
+        <p:nvSpPr>
+          <p:cNvPr id="4" name="TextBox 3"/>
+          <p:cNvSpPr txBox="1"/>
+          <p:nvPr/>
+        </p:nvSpPr>
+        <p:spPr>
+          <a:xfrm>
+            <a:off x="1810512" y="1298448"/>
+            <a:ext cx="4572000" cy="274320"/>
+          </a:xfrm>
+          <a:prstGeom prst="rect">
+            <a:avLst/>
+          </a:prstGeom>
+          <a:noFill/>
+        </p:spPr>
+        <p:txBody>
+          <a:bodyPr wrap="square">
+            <a:spAutoFit/>
+          </a:bodyPr>
+          <a:lstStyle/>
+          <a:p>
+            <a:pPr algn="l">
+              <a:defRPr sz="1300" b="1">
+                <a:solidFill>
+                  <a:srgbClr val="006A61"/>
+                </a:solidFill>
+                <a:latin typeface="SF Pro Display"/>
+              </a:defRPr>
+            </a:pPr>
+            <a:r>
+              <a:t>COMPLIANCE ENGINE</a:t>
+            </a:r>
+          </a:p>
+        </p:txBody>
+      </p:sp>
+      <p:sp>
+        <p:nvSpPr>
+          <p:cNvPr id="5" name="TextBox 4"/>
+          <p:cNvSpPr txBox="1"/>
+          <p:nvPr/>
+        </p:nvSpPr>
+        <p:spPr>
+          <a:xfrm>
+            <a:off x="731520" y="2286000"/>
             <a:ext cx="10515600" cy="1097280"/>
           </a:xfrm>
           <a:prstGeom prst="rect">
@@ -4359,13 +4431,13 @@
       </p:sp>
       <p:sp>
         <p:nvSpPr>
-          <p:cNvPr id="4" name="TextBox 3"/>
-          <p:cNvSpPr txBox="1"/>
-          <p:nvPr/>
-        </p:nvSpPr>
-        <p:spPr>
-          <a:xfrm>
-            <a:off x="731520" y="3108960"/>
+          <p:cNvPr id="6" name="TextBox 5"/>
+          <p:cNvSpPr txBox="1"/>
+          <p:nvPr/>
+        </p:nvSpPr>
+        <p:spPr>
+          <a:xfrm>
+            <a:off x="731520" y="3383280"/>
             <a:ext cx="10058400" cy="548640"/>
           </a:xfrm>
           <a:prstGeom prst="rect">
@@ -4395,13 +4467,13 @@
       </p:sp>
       <p:sp>
         <p:nvSpPr>
-          <p:cNvPr id="5" name="TextBox 4"/>
-          <p:cNvSpPr txBox="1"/>
-          <p:nvPr/>
-        </p:nvSpPr>
-        <p:spPr>
-          <a:xfrm>
-            <a:off x="731520" y="3794760"/>
+          <p:cNvPr id="7" name="TextBox 6"/>
+          <p:cNvSpPr txBox="1"/>
+          <p:nvPr/>
+        </p:nvSpPr>
+        <p:spPr>
+          <a:xfrm>
+            <a:off x="731520" y="4069080"/>
             <a:ext cx="10058400" cy="457200"/>
           </a:xfrm>
           <a:prstGeom prst="rect">
@@ -4431,13 +4503,96 @@
       </p:sp>
       <p:sp>
         <p:nvSpPr>
-          <p:cNvPr id="6" name="TextBox 5"/>
-          <p:cNvSpPr txBox="1"/>
-          <p:nvPr/>
-        </p:nvSpPr>
-        <p:spPr>
-          <a:xfrm>
-            <a:off x="731520" y="5303520"/>
+          <p:cNvPr id="8" name="Rounded Rectangle 7"/>
+          <p:cNvSpPr/>
+          <p:nvPr/>
+        </p:nvSpPr>
+        <p:spPr>
+          <a:xfrm>
+            <a:off x="731520" y="4800600"/>
+            <a:ext cx="2788920" cy="384048"/>
+          </a:xfrm>
+          <a:prstGeom prst="roundRect">
+            <a:avLst>
+              <a:gd name="adj" fmla="val 50000"/>
+            </a:avLst>
+          </a:prstGeom>
+          <a:solidFill>
+            <a:srgbClr val="DFFAF1"/>
+          </a:solidFill>
+          <a:ln w="12700">
+            <a:solidFill>
+              <a:srgbClr val="4EDEA3"/>
+            </a:solidFill>
+          </a:ln>
+        </p:spPr>
+        <p:style>
+          <a:lnRef idx="1">
+            <a:schemeClr val="accent1"/>
+          </a:lnRef>
+          <a:fillRef idx="3">
+            <a:schemeClr val="accent1"/>
+          </a:fillRef>
+          <a:effectRef idx="2">
+            <a:schemeClr val="accent1"/>
+          </a:effectRef>
+          <a:fontRef idx="minor">
+            <a:schemeClr val="lt1"/>
+          </a:fontRef>
+        </p:style>
+        <p:txBody>
+          <a:bodyPr rtlCol="0" anchor="ctr"/>
+          <a:lstStyle/>
+          <a:p>
+            <a:pPr algn="ctr"/>
+          </a:p>
+        </p:txBody>
+      </p:sp>
+      <p:sp>
+        <p:nvSpPr>
+          <p:cNvPr id="9" name="TextBox 8"/>
+          <p:cNvSpPr txBox="1"/>
+          <p:nvPr/>
+        </p:nvSpPr>
+        <p:spPr>
+          <a:xfrm>
+            <a:off x="731520" y="4864608"/>
+            <a:ext cx="2788920" cy="256032"/>
+          </a:xfrm>
+          <a:prstGeom prst="rect">
+            <a:avLst/>
+          </a:prstGeom>
+          <a:noFill/>
+        </p:spPr>
+        <p:txBody>
+          <a:bodyPr wrap="square">
+            <a:spAutoFit/>
+          </a:bodyPr>
+          <a:lstStyle/>
+          <a:p>
+            <a:pPr algn="ctr">
+              <a:defRPr sz="1300" b="1">
+                <a:solidFill>
+                  <a:srgbClr val="009668"/>
+                </a:solidFill>
+                <a:latin typeface="SF Pro Display"/>
+              </a:defRPr>
+            </a:pPr>
+            <a:r>
+              <a:t>✓  Stellar-Secured Receipts</a:t>
+            </a:r>
+          </a:p>
+        </p:txBody>
+      </p:sp>
+      <p:sp>
+        <p:nvSpPr>
+          <p:cNvPr id="10" name="TextBox 9"/>
+          <p:cNvSpPr txBox="1"/>
+          <p:nvPr/>
+        </p:nvSpPr>
+        <p:spPr>
+          <a:xfrm>
+            <a:off x="731520" y="5440680"/>
             <a:ext cx="10515600" cy="365760"/>
           </a:xfrm>
           <a:prstGeom prst="rect">
@@ -4467,13 +4622,13 @@
       </p:sp>
       <p:sp>
         <p:nvSpPr>
-          <p:cNvPr id="7" name="TextBox 6"/>
-          <p:cNvSpPr txBox="1"/>
-          <p:nvPr/>
-        </p:nvSpPr>
-        <p:spPr>
-          <a:xfrm>
-            <a:off x="731520" y="5669280"/>
+          <p:cNvPr id="11" name="TextBox 10"/>
+          <p:cNvSpPr txBox="1"/>
+          <p:nvPr/>
+        </p:nvSpPr>
+        <p:spPr>
+          <a:xfrm>
+            <a:off x="731520" y="5806440"/>
             <a:ext cx="10515600" cy="274320"/>
           </a:xfrm>
           <a:prstGeom prst="rect">
@@ -4503,7 +4658,7 @@
       </p:sp>
       <p:sp>
         <p:nvSpPr>
-          <p:cNvPr id="8" name="Rectangle 7"/>
+          <p:cNvPr id="12" name="Rectangle 11"/>
           <p:cNvSpPr/>
           <p:nvPr/>
         </p:nvSpPr>
@@ -4546,7 +4701,7 @@
       </p:sp>
       <p:pic>
         <p:nvPicPr>
-          <p:cNvPr id="9" name="Picture 8" descr="logo-colored-pptx.png"/>
+          <p:cNvPr id="13" name="Picture 12" descr="logo-colored-pptx.png"/>
           <p:cNvPicPr>
             <a:picLocks noChangeAspect="1"/>
           </p:cNvPicPr>
@@ -4570,14 +4725,14 @@
       </p:pic>
       <p:sp>
         <p:nvSpPr>
-          <p:cNvPr id="10" name="TextBox 9"/>
-          <p:cNvSpPr txBox="1"/>
-          <p:nvPr/>
-        </p:nvSpPr>
-        <p:spPr>
-          <a:xfrm>
-            <a:off x="960120" y="6446520"/>
-            <a:ext cx="2743200" cy="274320"/>
+          <p:cNvPr id="14" name="TextBox 13"/>
+          <p:cNvSpPr txBox="1"/>
+          <p:nvPr/>
+        </p:nvSpPr>
+        <p:spPr>
+          <a:xfrm>
+            <a:off x="960120" y="6419088"/>
+            <a:ext cx="2926080" cy="274320"/>
           </a:xfrm>
           <a:prstGeom prst="rect">
             <a:avLst/>
@@ -4599,21 +4754,57 @@
               </a:defRPr>
             </a:pPr>
             <a:r>
-              <a:t>Krunchr · Pitch Deck v3</a:t>
-            </a:r>
-          </a:p>
-        </p:txBody>
-      </p:sp>
-      <p:sp>
-        <p:nvSpPr>
-          <p:cNvPr id="11" name="TextBox 10"/>
-          <p:cNvSpPr txBox="1"/>
-          <p:nvPr/>
-        </p:nvSpPr>
-        <p:spPr>
-          <a:xfrm>
-            <a:off x="10607040" y="6446520"/>
-            <a:ext cx="1005840" cy="274320"/>
+              <a:t>Krunchr</a:t>
+            </a:r>
+          </a:p>
+        </p:txBody>
+      </p:sp>
+      <p:sp>
+        <p:nvSpPr>
+          <p:cNvPr id="15" name="TextBox 14"/>
+          <p:cNvSpPr txBox="1"/>
+          <p:nvPr/>
+        </p:nvSpPr>
+        <p:spPr>
+          <a:xfrm>
+            <a:off x="960120" y="6647688"/>
+            <a:ext cx="2926080" cy="201168"/>
+          </a:xfrm>
+          <a:prstGeom prst="rect">
+            <a:avLst/>
+          </a:prstGeom>
+          <a:noFill/>
+        </p:spPr>
+        <p:txBody>
+          <a:bodyPr wrap="square">
+            <a:spAutoFit/>
+          </a:bodyPr>
+          <a:lstStyle/>
+          <a:p>
+            <a:pPr algn="l">
+              <a:defRPr sz="900" b="0">
+                <a:solidFill>
+                  <a:srgbClr val="45464D"/>
+                </a:solidFill>
+                <a:latin typeface="SF Pro Display"/>
+              </a:defRPr>
+            </a:pPr>
+            <a:r>
+              <a:t>Compliance Engine</a:t>
+            </a:r>
+          </a:p>
+        </p:txBody>
+      </p:sp>
+      <p:sp>
+        <p:nvSpPr>
+          <p:cNvPr id="16" name="TextBox 15"/>
+          <p:cNvSpPr txBox="1"/>
+          <p:nvPr/>
+        </p:nvSpPr>
+        <p:spPr>
+          <a:xfrm>
+            <a:off x="9509760" y="6473952"/>
+            <a:ext cx="2103120" cy="274320"/>
           </a:xfrm>
           <a:prstGeom prst="rect">
             <a:avLst/>
@@ -4627,7 +4818,7 @@
           <a:lstStyle/>
           <a:p>
             <a:pPr algn="r">
-              <a:defRPr sz="1400" b="0">
+              <a:defRPr sz="1200" b="0">
                 <a:solidFill>
                   <a:srgbClr val="45464D"/>
                 </a:solidFill>
@@ -4635,7 +4826,7 @@
               </a:defRPr>
             </a:pPr>
             <a:r>
-              <a:t>1 / 12</a:t>
+              <a:t>Pitch Deck v3   ·   1 / 12</a:t>
             </a:r>
           </a:p>
         </p:txBody>
@@ -5002,8 +5193,8 @@
         </p:nvSpPr>
         <p:spPr>
           <a:xfrm>
-            <a:off x="960120" y="6446520"/>
-            <a:ext cx="2743200" cy="274320"/>
+            <a:off x="960120" y="6419088"/>
+            <a:ext cx="2926080" cy="274320"/>
           </a:xfrm>
           <a:prstGeom prst="rect">
             <a:avLst/>
@@ -5025,7 +5216,7 @@
               </a:defRPr>
             </a:pPr>
             <a:r>
-              <a:t>Krunchr · Pitch Deck v3</a:t>
+              <a:t>Krunchr</a:t>
             </a:r>
           </a:p>
         </p:txBody>
@@ -5038,8 +5229,44 @@
         </p:nvSpPr>
         <p:spPr>
           <a:xfrm>
-            <a:off x="10607040" y="6446520"/>
-            <a:ext cx="1005840" cy="274320"/>
+            <a:off x="960120" y="6647688"/>
+            <a:ext cx="2926080" cy="201168"/>
+          </a:xfrm>
+          <a:prstGeom prst="rect">
+            <a:avLst/>
+          </a:prstGeom>
+          <a:noFill/>
+        </p:spPr>
+        <p:txBody>
+          <a:bodyPr wrap="square">
+            <a:spAutoFit/>
+          </a:bodyPr>
+          <a:lstStyle/>
+          <a:p>
+            <a:pPr algn="l">
+              <a:defRPr sz="900" b="0">
+                <a:solidFill>
+                  <a:srgbClr val="45464D"/>
+                </a:solidFill>
+                <a:latin typeface="SF Pro Display"/>
+              </a:defRPr>
+            </a:pPr>
+            <a:r>
+              <a:t>Compliance Engine</a:t>
+            </a:r>
+          </a:p>
+        </p:txBody>
+      </p:sp>
+      <p:sp>
+        <p:nvSpPr>
+          <p:cNvPr id="11" name="TextBox 10"/>
+          <p:cNvSpPr txBox="1"/>
+          <p:nvPr/>
+        </p:nvSpPr>
+        <p:spPr>
+          <a:xfrm>
+            <a:off x="9509760" y="6473952"/>
+            <a:ext cx="2103120" cy="274320"/>
           </a:xfrm>
           <a:prstGeom prst="rect">
             <a:avLst/>
@@ -5053,7 +5280,7 @@
           <a:lstStyle/>
           <a:p>
             <a:pPr algn="r">
-              <a:defRPr sz="1400" b="0">
+              <a:defRPr sz="1200" b="0">
                 <a:solidFill>
                   <a:srgbClr val="45464D"/>
                 </a:solidFill>
@@ -5061,7 +5288,7 @@
               </a:defRPr>
             </a:pPr>
             <a:r>
-              <a:t>10 / 12</a:t>
+              <a:t>Pitch Deck v3   ·   10 / 12</a:t>
             </a:r>
           </a:p>
         </p:txBody>
@@ -5428,8 +5655,8 @@
         </p:nvSpPr>
         <p:spPr>
           <a:xfrm>
-            <a:off x="960120" y="6446520"/>
-            <a:ext cx="2743200" cy="274320"/>
+            <a:off x="960120" y="6419088"/>
+            <a:ext cx="2926080" cy="274320"/>
           </a:xfrm>
           <a:prstGeom prst="rect">
             <a:avLst/>
@@ -5451,7 +5678,7 @@
               </a:defRPr>
             </a:pPr>
             <a:r>
-              <a:t>Krunchr · Pitch Deck v3</a:t>
+              <a:t>Krunchr</a:t>
             </a:r>
           </a:p>
         </p:txBody>
@@ -5464,8 +5691,44 @@
         </p:nvSpPr>
         <p:spPr>
           <a:xfrm>
-            <a:off x="10607040" y="6446520"/>
-            <a:ext cx="1005840" cy="274320"/>
+            <a:off x="960120" y="6647688"/>
+            <a:ext cx="2926080" cy="201168"/>
+          </a:xfrm>
+          <a:prstGeom prst="rect">
+            <a:avLst/>
+          </a:prstGeom>
+          <a:noFill/>
+        </p:spPr>
+        <p:txBody>
+          <a:bodyPr wrap="square">
+            <a:spAutoFit/>
+          </a:bodyPr>
+          <a:lstStyle/>
+          <a:p>
+            <a:pPr algn="l">
+              <a:defRPr sz="900" b="0">
+                <a:solidFill>
+                  <a:srgbClr val="45464D"/>
+                </a:solidFill>
+                <a:latin typeface="SF Pro Display"/>
+              </a:defRPr>
+            </a:pPr>
+            <a:r>
+              <a:t>Compliance Engine</a:t>
+            </a:r>
+          </a:p>
+        </p:txBody>
+      </p:sp>
+      <p:sp>
+        <p:nvSpPr>
+          <p:cNvPr id="11" name="TextBox 10"/>
+          <p:cNvSpPr txBox="1"/>
+          <p:nvPr/>
+        </p:nvSpPr>
+        <p:spPr>
+          <a:xfrm>
+            <a:off x="9509760" y="6473952"/>
+            <a:ext cx="2103120" cy="274320"/>
           </a:xfrm>
           <a:prstGeom prst="rect">
             <a:avLst/>
@@ -5479,7 +5742,7 @@
           <a:lstStyle/>
           <a:p>
             <a:pPr algn="r">
-              <a:defRPr sz="1400" b="0">
+              <a:defRPr sz="1200" b="0">
                 <a:solidFill>
                   <a:srgbClr val="45464D"/>
                 </a:solidFill>
@@ -5487,7 +5750,7 @@
               </a:defRPr>
             </a:pPr>
             <a:r>
-              <a:t>11 / 12</a:t>
+              <a:t>Pitch Deck v3   ·   11 / 12</a:t>
             </a:r>
           </a:p>
         </p:txBody>
@@ -5626,7 +5889,9 @@
             <a:ext cx="1828800" cy="1828800"/>
           </a:xfrm>
           <a:prstGeom prst="roundRect">
-            <a:avLst/>
+            <a:avLst>
+              <a:gd name="adj" fmla="val 10000"/>
+            </a:avLst>
           </a:prstGeom>
           <a:solidFill>
             <a:srgbClr val="FFFFFF"/>
@@ -5636,6 +5901,13 @@
               <a:srgbClr val="E2E8F0"/>
             </a:solidFill>
           </a:ln>
+          <a:effectLst>
+            <a:outerShdw blurRad="76200" dist="34925" dir="5400000" rotWithShape="0">
+              <a:srgbClr val="0F172A">
+                <a:alpha val="14000"/>
+              </a:srgbClr>
+            </a:outerShdw>
+          </a:effectLst>
         </p:spPr>
         <p:style>
           <a:lnRef idx="1">
@@ -5786,7 +6058,9 @@
             <a:ext cx="1828800" cy="1828800"/>
           </a:xfrm>
           <a:prstGeom prst="roundRect">
-            <a:avLst/>
+            <a:avLst>
+              <a:gd name="adj" fmla="val 10000"/>
+            </a:avLst>
           </a:prstGeom>
           <a:solidFill>
             <a:srgbClr val="FFFFFF"/>
@@ -5796,6 +6070,13 @@
               <a:srgbClr val="E2E8F0"/>
             </a:solidFill>
           </a:ln>
+          <a:effectLst>
+            <a:outerShdw blurRad="76200" dist="34925" dir="5400000" rotWithShape="0">
+              <a:srgbClr val="0F172A">
+                <a:alpha val="14000"/>
+              </a:srgbClr>
+            </a:outerShdw>
+          </a:effectLst>
         </p:spPr>
         <p:style>
           <a:lnRef idx="1">
@@ -5946,7 +6227,9 @@
             <a:ext cx="1828800" cy="1828800"/>
           </a:xfrm>
           <a:prstGeom prst="roundRect">
-            <a:avLst/>
+            <a:avLst>
+              <a:gd name="adj" fmla="val 10000"/>
+            </a:avLst>
           </a:prstGeom>
           <a:solidFill>
             <a:srgbClr val="FFFFFF"/>
@@ -5956,6 +6239,13 @@
               <a:srgbClr val="E2E8F0"/>
             </a:solidFill>
           </a:ln>
+          <a:effectLst>
+            <a:outerShdw blurRad="76200" dist="34925" dir="5400000" rotWithShape="0">
+              <a:srgbClr val="0F172A">
+                <a:alpha val="14000"/>
+              </a:srgbClr>
+            </a:outerShdw>
+          </a:effectLst>
         </p:spPr>
         <p:style>
           <a:lnRef idx="1">
@@ -6241,8 +6531,8 @@
         </p:nvSpPr>
         <p:spPr>
           <a:xfrm>
-            <a:off x="960120" y="6446520"/>
-            <a:ext cx="2743200" cy="274320"/>
+            <a:off x="960120" y="6419088"/>
+            <a:ext cx="2926080" cy="274320"/>
           </a:xfrm>
           <a:prstGeom prst="rect">
             <a:avLst/>
@@ -6264,7 +6554,7 @@
               </a:defRPr>
             </a:pPr>
             <a:r>
-              <a:t>Krunchr · Pitch Deck v3</a:t>
+              <a:t>Krunchr</a:t>
             </a:r>
           </a:p>
         </p:txBody>
@@ -6277,8 +6567,44 @@
         </p:nvSpPr>
         <p:spPr>
           <a:xfrm>
-            <a:off x="10607040" y="6446520"/>
-            <a:ext cx="1005840" cy="274320"/>
+            <a:off x="960120" y="6647688"/>
+            <a:ext cx="2926080" cy="201168"/>
+          </a:xfrm>
+          <a:prstGeom prst="rect">
+            <a:avLst/>
+          </a:prstGeom>
+          <a:noFill/>
+        </p:spPr>
+        <p:txBody>
+          <a:bodyPr wrap="square">
+            <a:spAutoFit/>
+          </a:bodyPr>
+          <a:lstStyle/>
+          <a:p>
+            <a:pPr algn="l">
+              <a:defRPr sz="900" b="0">
+                <a:solidFill>
+                  <a:srgbClr val="45464D"/>
+                </a:solidFill>
+                <a:latin typeface="SF Pro Display"/>
+              </a:defRPr>
+            </a:pPr>
+            <a:r>
+              <a:t>Compliance Engine</a:t>
+            </a:r>
+          </a:p>
+        </p:txBody>
+      </p:sp>
+      <p:sp>
+        <p:nvSpPr>
+          <p:cNvPr id="23" name="TextBox 22"/>
+          <p:cNvSpPr txBox="1"/>
+          <p:nvPr/>
+        </p:nvSpPr>
+        <p:spPr>
+          <a:xfrm>
+            <a:off x="9509760" y="6473952"/>
+            <a:ext cx="2103120" cy="274320"/>
           </a:xfrm>
           <a:prstGeom prst="rect">
             <a:avLst/>
@@ -6292,7 +6618,7 @@
           <a:lstStyle/>
           <a:p>
             <a:pPr algn="r">
-              <a:defRPr sz="1400" b="0">
+              <a:defRPr sz="1200" b="0">
                 <a:solidFill>
                   <a:srgbClr val="45464D"/>
                 </a:solidFill>
@@ -6300,7 +6626,7 @@
               </a:defRPr>
             </a:pPr>
             <a:r>
-              <a:t>12 / 12</a:t>
+              <a:t>Pitch Deck v3   ·   12 / 12</a:t>
             </a:r>
           </a:p>
         </p:txBody>
@@ -6569,8 +6895,8 @@
         </p:nvSpPr>
         <p:spPr>
           <a:xfrm>
-            <a:off x="960120" y="6446520"/>
-            <a:ext cx="2743200" cy="274320"/>
+            <a:off x="960120" y="6419088"/>
+            <a:ext cx="2926080" cy="274320"/>
           </a:xfrm>
           <a:prstGeom prst="rect">
             <a:avLst/>
@@ -6592,7 +6918,7 @@
               </a:defRPr>
             </a:pPr>
             <a:r>
-              <a:t>Krunchr · Pitch Deck v3</a:t>
+              <a:t>Krunchr</a:t>
             </a:r>
           </a:p>
         </p:txBody>
@@ -6605,8 +6931,44 @@
         </p:nvSpPr>
         <p:spPr>
           <a:xfrm>
-            <a:off x="10607040" y="6446520"/>
-            <a:ext cx="1005840" cy="274320"/>
+            <a:off x="960120" y="6647688"/>
+            <a:ext cx="2926080" cy="201168"/>
+          </a:xfrm>
+          <a:prstGeom prst="rect">
+            <a:avLst/>
+          </a:prstGeom>
+          <a:noFill/>
+        </p:spPr>
+        <p:txBody>
+          <a:bodyPr wrap="square">
+            <a:spAutoFit/>
+          </a:bodyPr>
+          <a:lstStyle/>
+          <a:p>
+            <a:pPr algn="l">
+              <a:defRPr sz="900" b="0">
+                <a:solidFill>
+                  <a:srgbClr val="45464D"/>
+                </a:solidFill>
+                <a:latin typeface="SF Pro Display"/>
+              </a:defRPr>
+            </a:pPr>
+            <a:r>
+              <a:t>Compliance Engine</a:t>
+            </a:r>
+          </a:p>
+        </p:txBody>
+      </p:sp>
+      <p:sp>
+        <p:nvSpPr>
+          <p:cNvPr id="9" name="TextBox 8"/>
+          <p:cNvSpPr txBox="1"/>
+          <p:nvPr/>
+        </p:nvSpPr>
+        <p:spPr>
+          <a:xfrm>
+            <a:off x="9509760" y="6473952"/>
+            <a:ext cx="2103120" cy="274320"/>
           </a:xfrm>
           <a:prstGeom prst="rect">
             <a:avLst/>
@@ -6620,7 +6982,7 @@
           <a:lstStyle/>
           <a:p>
             <a:pPr algn="r">
-              <a:defRPr sz="1400" b="0">
+              <a:defRPr sz="1200" b="0">
                 <a:solidFill>
                   <a:srgbClr val="45464D"/>
                 </a:solidFill>
@@ -6628,7 +6990,133 @@
               </a:defRPr>
             </a:pPr>
             <a:r>
-              <a:t>2 / 12</a:t>
+              <a:t>Pitch Deck v3   ·   2 / 12</a:t>
+            </a:r>
+          </a:p>
+        </p:txBody>
+      </p:sp>
+      <p:sp>
+        <p:nvSpPr>
+          <p:cNvPr id="10" name="Rounded Rectangle 9"/>
+          <p:cNvSpPr/>
+          <p:nvPr/>
+        </p:nvSpPr>
+        <p:spPr>
+          <a:xfrm>
+            <a:off x="8915400" y="502920"/>
+            <a:ext cx="2514600" cy="329184"/>
+          </a:xfrm>
+          <a:prstGeom prst="roundRect">
+            <a:avLst>
+              <a:gd name="adj" fmla="val 50000"/>
+            </a:avLst>
+          </a:prstGeom>
+          <a:solidFill>
+            <a:srgbClr val="EFF4FF"/>
+          </a:solidFill>
+          <a:ln w="12700">
+            <a:solidFill>
+              <a:srgbClr val="E2E8F0"/>
+            </a:solidFill>
+          </a:ln>
+        </p:spPr>
+        <p:style>
+          <a:lnRef idx="1">
+            <a:schemeClr val="accent1"/>
+          </a:lnRef>
+          <a:fillRef idx="3">
+            <a:schemeClr val="accent1"/>
+          </a:fillRef>
+          <a:effectRef idx="2">
+            <a:schemeClr val="accent1"/>
+          </a:effectRef>
+          <a:fontRef idx="minor">
+            <a:schemeClr val="lt1"/>
+          </a:fontRef>
+        </p:style>
+        <p:txBody>
+          <a:bodyPr rtlCol="0" anchor="ctr"/>
+          <a:lstStyle/>
+          <a:p>
+            <a:pPr algn="ctr"/>
+          </a:p>
+        </p:txBody>
+      </p:sp>
+      <p:sp>
+        <p:nvSpPr>
+          <p:cNvPr id="11" name="Oval 10"/>
+          <p:cNvSpPr/>
+          <p:nvPr/>
+        </p:nvSpPr>
+        <p:spPr>
+          <a:xfrm>
+            <a:off x="9116568" y="621792"/>
+            <a:ext cx="100584" cy="100584"/>
+          </a:xfrm>
+          <a:prstGeom prst="ellipse">
+            <a:avLst/>
+          </a:prstGeom>
+          <a:solidFill>
+            <a:srgbClr val="009668"/>
+          </a:solidFill>
+          <a:ln>
+            <a:noFill/>
+          </a:ln>
+        </p:spPr>
+        <p:style>
+          <a:lnRef idx="1">
+            <a:schemeClr val="accent1"/>
+          </a:lnRef>
+          <a:fillRef idx="3">
+            <a:schemeClr val="accent1"/>
+          </a:fillRef>
+          <a:effectRef idx="2">
+            <a:schemeClr val="accent1"/>
+          </a:effectRef>
+          <a:fontRef idx="minor">
+            <a:schemeClr val="lt1"/>
+          </a:fontRef>
+        </p:style>
+        <p:txBody>
+          <a:bodyPr rtlCol="0" anchor="ctr"/>
+          <a:lstStyle/>
+          <a:p>
+            <a:pPr algn="ctr"/>
+          </a:p>
+        </p:txBody>
+      </p:sp>
+      <p:sp>
+        <p:nvSpPr>
+          <p:cNvPr id="12" name="TextBox 11"/>
+          <p:cNvSpPr txBox="1"/>
+          <p:nvPr/>
+        </p:nvSpPr>
+        <p:spPr>
+          <a:xfrm>
+            <a:off x="9299448" y="548640"/>
+            <a:ext cx="2057400" cy="256032"/>
+          </a:xfrm>
+          <a:prstGeom prst="rect">
+            <a:avLst/>
+          </a:prstGeom>
+          <a:noFill/>
+        </p:spPr>
+        <p:txBody>
+          <a:bodyPr wrap="square">
+            <a:spAutoFit/>
+          </a:bodyPr>
+          <a:lstStyle/>
+          <a:p>
+            <a:pPr algn="l">
+              <a:defRPr sz="1200" b="1">
+                <a:solidFill>
+                  <a:srgbClr val="006A61"/>
+                </a:solidFill>
+                <a:latin typeface="SF Pro Display"/>
+              </a:defRPr>
+            </a:pPr>
+            <a:r>
+              <a:t>Blockchain Status: Secured</a:t>
             </a:r>
           </a:p>
         </p:txBody>
@@ -6744,7 +7232,7 @@
           </a:xfrm>
           <a:prstGeom prst="roundRect">
             <a:avLst>
-              <a:gd name="adj" fmla="val 8000"/>
+              <a:gd name="adj" fmla="val 10000"/>
             </a:avLst>
           </a:prstGeom>
           <a:solidFill>
@@ -6755,6 +7243,13 @@
               <a:srgbClr val="E2E8F0"/>
             </a:solidFill>
           </a:ln>
+          <a:effectLst>
+            <a:outerShdw blurRad="76200" dist="34925" dir="5400000" rotWithShape="0">
+              <a:srgbClr val="0F172A">
+                <a:alpha val="14000"/>
+              </a:srgbClr>
+            </a:outerShdw>
+          </a:effectLst>
         </p:spPr>
         <p:style>
           <a:lnRef idx="1">
@@ -6942,7 +7437,7 @@
           </a:xfrm>
           <a:prstGeom prst="roundRect">
             <a:avLst>
-              <a:gd name="adj" fmla="val 8000"/>
+              <a:gd name="adj" fmla="val 10000"/>
             </a:avLst>
           </a:prstGeom>
           <a:solidFill>
@@ -6953,6 +7448,13 @@
               <a:srgbClr val="E2E8F0"/>
             </a:solidFill>
           </a:ln>
+          <a:effectLst>
+            <a:outerShdw blurRad="76200" dist="34925" dir="5400000" rotWithShape="0">
+              <a:srgbClr val="0F172A">
+                <a:alpha val="14000"/>
+              </a:srgbClr>
+            </a:outerShdw>
+          </a:effectLst>
         </p:spPr>
         <p:style>
           <a:lnRef idx="1">
@@ -7140,7 +7642,7 @@
           </a:xfrm>
           <a:prstGeom prst="roundRect">
             <a:avLst>
-              <a:gd name="adj" fmla="val 8000"/>
+              <a:gd name="adj" fmla="val 10000"/>
             </a:avLst>
           </a:prstGeom>
           <a:solidFill>
@@ -7151,6 +7653,13 @@
               <a:srgbClr val="E2E8F0"/>
             </a:solidFill>
           </a:ln>
+          <a:effectLst>
+            <a:outerShdw blurRad="76200" dist="34925" dir="5400000" rotWithShape="0">
+              <a:srgbClr val="0F172A">
+                <a:alpha val="14000"/>
+              </a:srgbClr>
+            </a:outerShdw>
+          </a:effectLst>
         </p:spPr>
         <p:style>
           <a:lnRef idx="1">
@@ -7338,7 +7847,7 @@
           </a:xfrm>
           <a:prstGeom prst="roundRect">
             <a:avLst>
-              <a:gd name="adj" fmla="val 8000"/>
+              <a:gd name="adj" fmla="val 10000"/>
             </a:avLst>
           </a:prstGeom>
           <a:solidFill>
@@ -7349,6 +7858,13 @@
               <a:srgbClr val="E2E8F0"/>
             </a:solidFill>
           </a:ln>
+          <a:effectLst>
+            <a:outerShdw blurRad="76200" dist="34925" dir="5400000" rotWithShape="0">
+              <a:srgbClr val="0F172A">
+                <a:alpha val="14000"/>
+              </a:srgbClr>
+            </a:outerShdw>
+          </a:effectLst>
         </p:spPr>
         <p:style>
           <a:lnRef idx="1">
@@ -7598,8 +8114,8 @@
         </p:nvSpPr>
         <p:spPr>
           <a:xfrm>
-            <a:off x="960120" y="6446520"/>
-            <a:ext cx="2743200" cy="274320"/>
+            <a:off x="960120" y="6419088"/>
+            <a:ext cx="2926080" cy="274320"/>
           </a:xfrm>
           <a:prstGeom prst="rect">
             <a:avLst/>
@@ -7621,7 +8137,7 @@
               </a:defRPr>
             </a:pPr>
             <a:r>
-              <a:t>Krunchr · Pitch Deck v3</a:t>
+              <a:t>Krunchr</a:t>
             </a:r>
           </a:p>
         </p:txBody>
@@ -7634,8 +8150,44 @@
         </p:nvSpPr>
         <p:spPr>
           <a:xfrm>
-            <a:off x="10607040" y="6446520"/>
-            <a:ext cx="1005840" cy="274320"/>
+            <a:off x="960120" y="6647688"/>
+            <a:ext cx="2926080" cy="201168"/>
+          </a:xfrm>
+          <a:prstGeom prst="rect">
+            <a:avLst/>
+          </a:prstGeom>
+          <a:noFill/>
+        </p:spPr>
+        <p:txBody>
+          <a:bodyPr wrap="square">
+            <a:spAutoFit/>
+          </a:bodyPr>
+          <a:lstStyle/>
+          <a:p>
+            <a:pPr algn="l">
+              <a:defRPr sz="900" b="0">
+                <a:solidFill>
+                  <a:srgbClr val="45464D"/>
+                </a:solidFill>
+                <a:latin typeface="SF Pro Display"/>
+              </a:defRPr>
+            </a:pPr>
+            <a:r>
+              <a:t>Compliance Engine</a:t>
+            </a:r>
+          </a:p>
+        </p:txBody>
+      </p:sp>
+      <p:sp>
+        <p:nvSpPr>
+          <p:cNvPr id="28" name="TextBox 27"/>
+          <p:cNvSpPr txBox="1"/>
+          <p:nvPr/>
+        </p:nvSpPr>
+        <p:spPr>
+          <a:xfrm>
+            <a:off x="9509760" y="6473952"/>
+            <a:ext cx="2103120" cy="274320"/>
           </a:xfrm>
           <a:prstGeom prst="rect">
             <a:avLst/>
@@ -7649,7 +8201,7 @@
           <a:lstStyle/>
           <a:p>
             <a:pPr algn="r">
-              <a:defRPr sz="1400" b="0">
+              <a:defRPr sz="1200" b="0">
                 <a:solidFill>
                   <a:srgbClr val="45464D"/>
                 </a:solidFill>
@@ -7657,7 +8209,133 @@
               </a:defRPr>
             </a:pPr>
             <a:r>
-              <a:t>3 / 12</a:t>
+              <a:t>Pitch Deck v3   ·   3 / 12</a:t>
+            </a:r>
+          </a:p>
+        </p:txBody>
+      </p:sp>
+      <p:sp>
+        <p:nvSpPr>
+          <p:cNvPr id="29" name="Rounded Rectangle 28"/>
+          <p:cNvSpPr/>
+          <p:nvPr/>
+        </p:nvSpPr>
+        <p:spPr>
+          <a:xfrm>
+            <a:off x="8915400" y="502920"/>
+            <a:ext cx="2514600" cy="329184"/>
+          </a:xfrm>
+          <a:prstGeom prst="roundRect">
+            <a:avLst>
+              <a:gd name="adj" fmla="val 50000"/>
+            </a:avLst>
+          </a:prstGeom>
+          <a:solidFill>
+            <a:srgbClr val="EFF4FF"/>
+          </a:solidFill>
+          <a:ln w="12700">
+            <a:solidFill>
+              <a:srgbClr val="E2E8F0"/>
+            </a:solidFill>
+          </a:ln>
+        </p:spPr>
+        <p:style>
+          <a:lnRef idx="1">
+            <a:schemeClr val="accent1"/>
+          </a:lnRef>
+          <a:fillRef idx="3">
+            <a:schemeClr val="accent1"/>
+          </a:fillRef>
+          <a:effectRef idx="2">
+            <a:schemeClr val="accent1"/>
+          </a:effectRef>
+          <a:fontRef idx="minor">
+            <a:schemeClr val="lt1"/>
+          </a:fontRef>
+        </p:style>
+        <p:txBody>
+          <a:bodyPr rtlCol="0" anchor="ctr"/>
+          <a:lstStyle/>
+          <a:p>
+            <a:pPr algn="ctr"/>
+          </a:p>
+        </p:txBody>
+      </p:sp>
+      <p:sp>
+        <p:nvSpPr>
+          <p:cNvPr id="30" name="Oval 29"/>
+          <p:cNvSpPr/>
+          <p:nvPr/>
+        </p:nvSpPr>
+        <p:spPr>
+          <a:xfrm>
+            <a:off x="9116568" y="621792"/>
+            <a:ext cx="100584" cy="100584"/>
+          </a:xfrm>
+          <a:prstGeom prst="ellipse">
+            <a:avLst/>
+          </a:prstGeom>
+          <a:solidFill>
+            <a:srgbClr val="009668"/>
+          </a:solidFill>
+          <a:ln>
+            <a:noFill/>
+          </a:ln>
+        </p:spPr>
+        <p:style>
+          <a:lnRef idx="1">
+            <a:schemeClr val="accent1"/>
+          </a:lnRef>
+          <a:fillRef idx="3">
+            <a:schemeClr val="accent1"/>
+          </a:fillRef>
+          <a:effectRef idx="2">
+            <a:schemeClr val="accent1"/>
+          </a:effectRef>
+          <a:fontRef idx="minor">
+            <a:schemeClr val="lt1"/>
+          </a:fontRef>
+        </p:style>
+        <p:txBody>
+          <a:bodyPr rtlCol="0" anchor="ctr"/>
+          <a:lstStyle/>
+          <a:p>
+            <a:pPr algn="ctr"/>
+          </a:p>
+        </p:txBody>
+      </p:sp>
+      <p:sp>
+        <p:nvSpPr>
+          <p:cNvPr id="31" name="TextBox 30"/>
+          <p:cNvSpPr txBox="1"/>
+          <p:nvPr/>
+        </p:nvSpPr>
+        <p:spPr>
+          <a:xfrm>
+            <a:off x="9299448" y="548640"/>
+            <a:ext cx="2057400" cy="256032"/>
+          </a:xfrm>
+          <a:prstGeom prst="rect">
+            <a:avLst/>
+          </a:prstGeom>
+          <a:noFill/>
+        </p:spPr>
+        <p:txBody>
+          <a:bodyPr wrap="square">
+            <a:spAutoFit/>
+          </a:bodyPr>
+          <a:lstStyle/>
+          <a:p>
+            <a:pPr algn="l">
+              <a:defRPr sz="1200" b="1">
+                <a:solidFill>
+                  <a:srgbClr val="006A61"/>
+                </a:solidFill>
+                <a:latin typeface="SF Pro Display"/>
+              </a:defRPr>
+            </a:pPr>
+            <a:r>
+              <a:t>Blockchain Status: Secured</a:t>
             </a:r>
           </a:p>
         </p:txBody>
@@ -7809,7 +8487,7 @@
           </a:xfrm>
           <a:prstGeom prst="roundRect">
             <a:avLst>
-              <a:gd name="adj" fmla="val 8000"/>
+              <a:gd name="adj" fmla="val 10000"/>
             </a:avLst>
           </a:prstGeom>
           <a:solidFill>
@@ -7820,6 +8498,13 @@
               <a:srgbClr val="E2E8F0"/>
             </a:solidFill>
           </a:ln>
+          <a:effectLst>
+            <a:outerShdw blurRad="76200" dist="34925" dir="5400000" rotWithShape="0">
+              <a:srgbClr val="0F172A">
+                <a:alpha val="14000"/>
+              </a:srgbClr>
+            </a:outerShdw>
+          </a:effectLst>
         </p:spPr>
         <p:style>
           <a:lnRef idx="1">
@@ -8007,7 +8692,7 @@
           </a:xfrm>
           <a:prstGeom prst="roundRect">
             <a:avLst>
-              <a:gd name="adj" fmla="val 8000"/>
+              <a:gd name="adj" fmla="val 10000"/>
             </a:avLst>
           </a:prstGeom>
           <a:solidFill>
@@ -8018,6 +8703,13 @@
               <a:srgbClr val="E2E8F0"/>
             </a:solidFill>
           </a:ln>
+          <a:effectLst>
+            <a:outerShdw blurRad="76200" dist="34925" dir="5400000" rotWithShape="0">
+              <a:srgbClr val="0F172A">
+                <a:alpha val="14000"/>
+              </a:srgbClr>
+            </a:outerShdw>
+          </a:effectLst>
         </p:spPr>
         <p:style>
           <a:lnRef idx="1">
@@ -8205,7 +8897,7 @@
           </a:xfrm>
           <a:prstGeom prst="roundRect">
             <a:avLst>
-              <a:gd name="adj" fmla="val 8000"/>
+              <a:gd name="adj" fmla="val 10000"/>
             </a:avLst>
           </a:prstGeom>
           <a:solidFill>
@@ -8216,6 +8908,13 @@
               <a:srgbClr val="E2E8F0"/>
             </a:solidFill>
           </a:ln>
+          <a:effectLst>
+            <a:outerShdw blurRad="76200" dist="34925" dir="5400000" rotWithShape="0">
+              <a:srgbClr val="0F172A">
+                <a:alpha val="14000"/>
+              </a:srgbClr>
+            </a:outerShdw>
+          </a:effectLst>
         </p:spPr>
         <p:style>
           <a:lnRef idx="1">
@@ -8403,7 +9102,7 @@
           </a:xfrm>
           <a:prstGeom prst="roundRect">
             <a:avLst>
-              <a:gd name="adj" fmla="val 8000"/>
+              <a:gd name="adj" fmla="val 10000"/>
             </a:avLst>
           </a:prstGeom>
           <a:solidFill>
@@ -8414,6 +9113,13 @@
               <a:srgbClr val="E2E8F0"/>
             </a:solidFill>
           </a:ln>
+          <a:effectLst>
+            <a:outerShdw blurRad="76200" dist="34925" dir="5400000" rotWithShape="0">
+              <a:srgbClr val="0F172A">
+                <a:alpha val="14000"/>
+              </a:srgbClr>
+            </a:outerShdw>
+          </a:effectLst>
         </p:spPr>
         <p:style>
           <a:lnRef idx="1">
@@ -8601,7 +9307,7 @@
           </a:xfrm>
           <a:prstGeom prst="roundRect">
             <a:avLst>
-              <a:gd name="adj" fmla="val 8000"/>
+              <a:gd name="adj" fmla="val 10000"/>
             </a:avLst>
           </a:prstGeom>
           <a:solidFill>
@@ -8612,6 +9318,13 @@
               <a:srgbClr val="E2E8F0"/>
             </a:solidFill>
           </a:ln>
+          <a:effectLst>
+            <a:outerShdw blurRad="76200" dist="34925" dir="5400000" rotWithShape="0">
+              <a:srgbClr val="0F172A">
+                <a:alpha val="14000"/>
+              </a:srgbClr>
+            </a:outerShdw>
+          </a:effectLst>
         </p:spPr>
         <p:style>
           <a:lnRef idx="1">
@@ -8808,6 +9521,13 @@
               <a:srgbClr val="E2E8F0"/>
             </a:solidFill>
           </a:ln>
+          <a:effectLst>
+            <a:outerShdw blurRad="76200" dist="34925" dir="5400000" rotWithShape="0">
+              <a:srgbClr val="0F172A">
+                <a:alpha val="14000"/>
+              </a:srgbClr>
+            </a:outerShdw>
+          </a:effectLst>
         </p:spPr>
         <p:style>
           <a:lnRef idx="1">
@@ -8942,8 +9662,8 @@
         </p:nvSpPr>
         <p:spPr>
           <a:xfrm>
-            <a:off x="960120" y="6446520"/>
-            <a:ext cx="2743200" cy="274320"/>
+            <a:off x="960120" y="6419088"/>
+            <a:ext cx="2926080" cy="274320"/>
           </a:xfrm>
           <a:prstGeom prst="rect">
             <a:avLst/>
@@ -8965,7 +9685,7 @@
               </a:defRPr>
             </a:pPr>
             <a:r>
-              <a:t>Krunchr · Pitch Deck v3</a:t>
+              <a:t>Krunchr</a:t>
             </a:r>
           </a:p>
         </p:txBody>
@@ -8978,8 +9698,44 @@
         </p:nvSpPr>
         <p:spPr>
           <a:xfrm>
-            <a:off x="10607040" y="6446520"/>
-            <a:ext cx="1005840" cy="274320"/>
+            <a:off x="960120" y="6647688"/>
+            <a:ext cx="2926080" cy="201168"/>
+          </a:xfrm>
+          <a:prstGeom prst="rect">
+            <a:avLst/>
+          </a:prstGeom>
+          <a:noFill/>
+        </p:spPr>
+        <p:txBody>
+          <a:bodyPr wrap="square">
+            <a:spAutoFit/>
+          </a:bodyPr>
+          <a:lstStyle/>
+          <a:p>
+            <a:pPr algn="l">
+              <a:defRPr sz="900" b="0">
+                <a:solidFill>
+                  <a:srgbClr val="45464D"/>
+                </a:solidFill>
+                <a:latin typeface="SF Pro Display"/>
+              </a:defRPr>
+            </a:pPr>
+            <a:r>
+              <a:t>Compliance Engine</a:t>
+            </a:r>
+          </a:p>
+        </p:txBody>
+      </p:sp>
+      <p:sp>
+        <p:nvSpPr>
+          <p:cNvPr id="36" name="TextBox 35"/>
+          <p:cNvSpPr txBox="1"/>
+          <p:nvPr/>
+        </p:nvSpPr>
+        <p:spPr>
+          <a:xfrm>
+            <a:off x="9509760" y="6473952"/>
+            <a:ext cx="2103120" cy="274320"/>
           </a:xfrm>
           <a:prstGeom prst="rect">
             <a:avLst/>
@@ -8993,7 +9749,7 @@
           <a:lstStyle/>
           <a:p>
             <a:pPr algn="r">
-              <a:defRPr sz="1400" b="0">
+              <a:defRPr sz="1200" b="0">
                 <a:solidFill>
                   <a:srgbClr val="45464D"/>
                 </a:solidFill>
@@ -9001,7 +9757,133 @@
               </a:defRPr>
             </a:pPr>
             <a:r>
-              <a:t>4 / 12</a:t>
+              <a:t>Pitch Deck v3   ·   4 / 12</a:t>
+            </a:r>
+          </a:p>
+        </p:txBody>
+      </p:sp>
+      <p:sp>
+        <p:nvSpPr>
+          <p:cNvPr id="37" name="Rounded Rectangle 36"/>
+          <p:cNvSpPr/>
+          <p:nvPr/>
+        </p:nvSpPr>
+        <p:spPr>
+          <a:xfrm>
+            <a:off x="8915400" y="502920"/>
+            <a:ext cx="2514600" cy="329184"/>
+          </a:xfrm>
+          <a:prstGeom prst="roundRect">
+            <a:avLst>
+              <a:gd name="adj" fmla="val 50000"/>
+            </a:avLst>
+          </a:prstGeom>
+          <a:solidFill>
+            <a:srgbClr val="EFF4FF"/>
+          </a:solidFill>
+          <a:ln w="12700">
+            <a:solidFill>
+              <a:srgbClr val="E2E8F0"/>
+            </a:solidFill>
+          </a:ln>
+        </p:spPr>
+        <p:style>
+          <a:lnRef idx="1">
+            <a:schemeClr val="accent1"/>
+          </a:lnRef>
+          <a:fillRef idx="3">
+            <a:schemeClr val="accent1"/>
+          </a:fillRef>
+          <a:effectRef idx="2">
+            <a:schemeClr val="accent1"/>
+          </a:effectRef>
+          <a:fontRef idx="minor">
+            <a:schemeClr val="lt1"/>
+          </a:fontRef>
+        </p:style>
+        <p:txBody>
+          <a:bodyPr rtlCol="0" anchor="ctr"/>
+          <a:lstStyle/>
+          <a:p>
+            <a:pPr algn="ctr"/>
+          </a:p>
+        </p:txBody>
+      </p:sp>
+      <p:sp>
+        <p:nvSpPr>
+          <p:cNvPr id="38" name="Oval 37"/>
+          <p:cNvSpPr/>
+          <p:nvPr/>
+        </p:nvSpPr>
+        <p:spPr>
+          <a:xfrm>
+            <a:off x="9116568" y="621792"/>
+            <a:ext cx="100584" cy="100584"/>
+          </a:xfrm>
+          <a:prstGeom prst="ellipse">
+            <a:avLst/>
+          </a:prstGeom>
+          <a:solidFill>
+            <a:srgbClr val="009668"/>
+          </a:solidFill>
+          <a:ln>
+            <a:noFill/>
+          </a:ln>
+        </p:spPr>
+        <p:style>
+          <a:lnRef idx="1">
+            <a:schemeClr val="accent1"/>
+          </a:lnRef>
+          <a:fillRef idx="3">
+            <a:schemeClr val="accent1"/>
+          </a:fillRef>
+          <a:effectRef idx="2">
+            <a:schemeClr val="accent1"/>
+          </a:effectRef>
+          <a:fontRef idx="minor">
+            <a:schemeClr val="lt1"/>
+          </a:fontRef>
+        </p:style>
+        <p:txBody>
+          <a:bodyPr rtlCol="0" anchor="ctr"/>
+          <a:lstStyle/>
+          <a:p>
+            <a:pPr algn="ctr"/>
+          </a:p>
+        </p:txBody>
+      </p:sp>
+      <p:sp>
+        <p:nvSpPr>
+          <p:cNvPr id="39" name="TextBox 38"/>
+          <p:cNvSpPr txBox="1"/>
+          <p:nvPr/>
+        </p:nvSpPr>
+        <p:spPr>
+          <a:xfrm>
+            <a:off x="9299448" y="548640"/>
+            <a:ext cx="2057400" cy="256032"/>
+          </a:xfrm>
+          <a:prstGeom prst="rect">
+            <a:avLst/>
+          </a:prstGeom>
+          <a:noFill/>
+        </p:spPr>
+        <p:txBody>
+          <a:bodyPr wrap="square">
+            <a:spAutoFit/>
+          </a:bodyPr>
+          <a:lstStyle/>
+          <a:p>
+            <a:pPr algn="l">
+              <a:defRPr sz="1200" b="1">
+                <a:solidFill>
+                  <a:srgbClr val="006A61"/>
+                </a:solidFill>
+                <a:latin typeface="SF Pro Display"/>
+              </a:defRPr>
+            </a:pPr>
+            <a:r>
+              <a:t>Blockchain Status: Secured</a:t>
             </a:r>
           </a:p>
         </p:txBody>
@@ -9126,6 +10008,13 @@
               <a:srgbClr val="E2E8F0"/>
             </a:solidFill>
           </a:ln>
+          <a:effectLst>
+            <a:outerShdw blurRad="76200" dist="34925" dir="5400000" rotWithShape="0">
+              <a:srgbClr val="0F172A">
+                <a:alpha val="14000"/>
+              </a:srgbClr>
+            </a:outerShdw>
+          </a:effectLst>
         </p:spPr>
         <p:style>
           <a:lnRef idx="1">
@@ -9279,6 +10168,13 @@
               <a:srgbClr val="E2E8F0"/>
             </a:solidFill>
           </a:ln>
+          <a:effectLst>
+            <a:outerShdw blurRad="76200" dist="34925" dir="5400000" rotWithShape="0">
+              <a:srgbClr val="0F172A">
+                <a:alpha val="14000"/>
+              </a:srgbClr>
+            </a:outerShdw>
+          </a:effectLst>
         </p:spPr>
         <p:style>
           <a:lnRef idx="1">
@@ -9432,6 +10328,13 @@
               <a:srgbClr val="E2E8F0"/>
             </a:solidFill>
           </a:ln>
+          <a:effectLst>
+            <a:outerShdw blurRad="76200" dist="34925" dir="5400000" rotWithShape="0">
+              <a:srgbClr val="0F172A">
+                <a:alpha val="14000"/>
+              </a:srgbClr>
+            </a:outerShdw>
+          </a:effectLst>
         </p:spPr>
         <p:style>
           <a:lnRef idx="1">
@@ -9585,6 +10488,13 @@
               <a:srgbClr val="E2E8F0"/>
             </a:solidFill>
           </a:ln>
+          <a:effectLst>
+            <a:outerShdw blurRad="76200" dist="34925" dir="5400000" rotWithShape="0">
+              <a:srgbClr val="0F172A">
+                <a:alpha val="14000"/>
+              </a:srgbClr>
+            </a:outerShdw>
+          </a:effectLst>
         </p:spPr>
         <p:style>
           <a:lnRef idx="1">
@@ -9846,8 +10756,8 @@
         </p:nvSpPr>
         <p:spPr>
           <a:xfrm>
-            <a:off x="960120" y="6446520"/>
-            <a:ext cx="2743200" cy="274320"/>
+            <a:off x="960120" y="6419088"/>
+            <a:ext cx="2926080" cy="274320"/>
           </a:xfrm>
           <a:prstGeom prst="rect">
             <a:avLst/>
@@ -9869,7 +10779,7 @@
               </a:defRPr>
             </a:pPr>
             <a:r>
-              <a:t>Krunchr · Pitch Deck v3</a:t>
+              <a:t>Krunchr</a:t>
             </a:r>
           </a:p>
         </p:txBody>
@@ -9882,8 +10792,44 @@
         </p:nvSpPr>
         <p:spPr>
           <a:xfrm>
-            <a:off x="10607040" y="6446520"/>
-            <a:ext cx="1005840" cy="274320"/>
+            <a:off x="960120" y="6647688"/>
+            <a:ext cx="2926080" cy="201168"/>
+          </a:xfrm>
+          <a:prstGeom prst="rect">
+            <a:avLst/>
+          </a:prstGeom>
+          <a:noFill/>
+        </p:spPr>
+        <p:txBody>
+          <a:bodyPr wrap="square">
+            <a:spAutoFit/>
+          </a:bodyPr>
+          <a:lstStyle/>
+          <a:p>
+            <a:pPr algn="l">
+              <a:defRPr sz="900" b="0">
+                <a:solidFill>
+                  <a:srgbClr val="45464D"/>
+                </a:solidFill>
+                <a:latin typeface="SF Pro Display"/>
+              </a:defRPr>
+            </a:pPr>
+            <a:r>
+              <a:t>Compliance Engine</a:t>
+            </a:r>
+          </a:p>
+        </p:txBody>
+      </p:sp>
+      <p:sp>
+        <p:nvSpPr>
+          <p:cNvPr id="24" name="TextBox 23"/>
+          <p:cNvSpPr txBox="1"/>
+          <p:nvPr/>
+        </p:nvSpPr>
+        <p:spPr>
+          <a:xfrm>
+            <a:off x="9509760" y="6473952"/>
+            <a:ext cx="2103120" cy="274320"/>
           </a:xfrm>
           <a:prstGeom prst="rect">
             <a:avLst/>
@@ -9897,7 +10843,7 @@
           <a:lstStyle/>
           <a:p>
             <a:pPr algn="r">
-              <a:defRPr sz="1400" b="0">
+              <a:defRPr sz="1200" b="0">
                 <a:solidFill>
                   <a:srgbClr val="45464D"/>
                 </a:solidFill>
@@ -9905,7 +10851,133 @@
               </a:defRPr>
             </a:pPr>
             <a:r>
-              <a:t>5 / 12</a:t>
+              <a:t>Pitch Deck v3   ·   5 / 12</a:t>
+            </a:r>
+          </a:p>
+        </p:txBody>
+      </p:sp>
+      <p:sp>
+        <p:nvSpPr>
+          <p:cNvPr id="25" name="Rounded Rectangle 24"/>
+          <p:cNvSpPr/>
+          <p:nvPr/>
+        </p:nvSpPr>
+        <p:spPr>
+          <a:xfrm>
+            <a:off x="8915400" y="502920"/>
+            <a:ext cx="2514600" cy="329184"/>
+          </a:xfrm>
+          <a:prstGeom prst="roundRect">
+            <a:avLst>
+              <a:gd name="adj" fmla="val 50000"/>
+            </a:avLst>
+          </a:prstGeom>
+          <a:solidFill>
+            <a:srgbClr val="EFF4FF"/>
+          </a:solidFill>
+          <a:ln w="12700">
+            <a:solidFill>
+              <a:srgbClr val="E2E8F0"/>
+            </a:solidFill>
+          </a:ln>
+        </p:spPr>
+        <p:style>
+          <a:lnRef idx="1">
+            <a:schemeClr val="accent1"/>
+          </a:lnRef>
+          <a:fillRef idx="3">
+            <a:schemeClr val="accent1"/>
+          </a:fillRef>
+          <a:effectRef idx="2">
+            <a:schemeClr val="accent1"/>
+          </a:effectRef>
+          <a:fontRef idx="minor">
+            <a:schemeClr val="lt1"/>
+          </a:fontRef>
+        </p:style>
+        <p:txBody>
+          <a:bodyPr rtlCol="0" anchor="ctr"/>
+          <a:lstStyle/>
+          <a:p>
+            <a:pPr algn="ctr"/>
+          </a:p>
+        </p:txBody>
+      </p:sp>
+      <p:sp>
+        <p:nvSpPr>
+          <p:cNvPr id="26" name="Oval 25"/>
+          <p:cNvSpPr/>
+          <p:nvPr/>
+        </p:nvSpPr>
+        <p:spPr>
+          <a:xfrm>
+            <a:off x="9116568" y="621792"/>
+            <a:ext cx="100584" cy="100584"/>
+          </a:xfrm>
+          <a:prstGeom prst="ellipse">
+            <a:avLst/>
+          </a:prstGeom>
+          <a:solidFill>
+            <a:srgbClr val="009668"/>
+          </a:solidFill>
+          <a:ln>
+            <a:noFill/>
+          </a:ln>
+        </p:spPr>
+        <p:style>
+          <a:lnRef idx="1">
+            <a:schemeClr val="accent1"/>
+          </a:lnRef>
+          <a:fillRef idx="3">
+            <a:schemeClr val="accent1"/>
+          </a:fillRef>
+          <a:effectRef idx="2">
+            <a:schemeClr val="accent1"/>
+          </a:effectRef>
+          <a:fontRef idx="minor">
+            <a:schemeClr val="lt1"/>
+          </a:fontRef>
+        </p:style>
+        <p:txBody>
+          <a:bodyPr rtlCol="0" anchor="ctr"/>
+          <a:lstStyle/>
+          <a:p>
+            <a:pPr algn="ctr"/>
+          </a:p>
+        </p:txBody>
+      </p:sp>
+      <p:sp>
+        <p:nvSpPr>
+          <p:cNvPr id="27" name="TextBox 26"/>
+          <p:cNvSpPr txBox="1"/>
+          <p:nvPr/>
+        </p:nvSpPr>
+        <p:spPr>
+          <a:xfrm>
+            <a:off x="9299448" y="548640"/>
+            <a:ext cx="2057400" cy="256032"/>
+          </a:xfrm>
+          <a:prstGeom prst="rect">
+            <a:avLst/>
+          </a:prstGeom>
+          <a:noFill/>
+        </p:spPr>
+        <p:txBody>
+          <a:bodyPr wrap="square">
+            <a:spAutoFit/>
+          </a:bodyPr>
+          <a:lstStyle/>
+          <a:p>
+            <a:pPr algn="l">
+              <a:defRPr sz="1200" b="1">
+                <a:solidFill>
+                  <a:srgbClr val="006A61"/>
+                </a:solidFill>
+                <a:latin typeface="SF Pro Display"/>
+              </a:defRPr>
+            </a:pPr>
+            <a:r>
+              <a:t>Blockchain Status: Secured</a:t>
             </a:r>
           </a:p>
         </p:txBody>
@@ -10191,8 +11263,8 @@
         </p:nvSpPr>
         <p:spPr>
           <a:xfrm>
-            <a:off x="960120" y="6446520"/>
-            <a:ext cx="2743200" cy="274320"/>
+            <a:off x="960120" y="6419088"/>
+            <a:ext cx="2926080" cy="274320"/>
           </a:xfrm>
           <a:prstGeom prst="rect">
             <a:avLst/>
@@ -10214,7 +11286,7 @@
               </a:defRPr>
             </a:pPr>
             <a:r>
-              <a:t>Krunchr · Pitch Deck v3</a:t>
+              <a:t>Krunchr</a:t>
             </a:r>
           </a:p>
         </p:txBody>
@@ -10227,8 +11299,44 @@
         </p:nvSpPr>
         <p:spPr>
           <a:xfrm>
-            <a:off x="10607040" y="6446520"/>
-            <a:ext cx="1005840" cy="274320"/>
+            <a:off x="960120" y="6647688"/>
+            <a:ext cx="2926080" cy="201168"/>
+          </a:xfrm>
+          <a:prstGeom prst="rect">
+            <a:avLst/>
+          </a:prstGeom>
+          <a:noFill/>
+        </p:spPr>
+        <p:txBody>
+          <a:bodyPr wrap="square">
+            <a:spAutoFit/>
+          </a:bodyPr>
+          <a:lstStyle/>
+          <a:p>
+            <a:pPr algn="l">
+              <a:defRPr sz="900" b="0">
+                <a:solidFill>
+                  <a:srgbClr val="45464D"/>
+                </a:solidFill>
+                <a:latin typeface="SF Pro Display"/>
+              </a:defRPr>
+            </a:pPr>
+            <a:r>
+              <a:t>Compliance Engine</a:t>
+            </a:r>
+          </a:p>
+        </p:txBody>
+      </p:sp>
+      <p:sp>
+        <p:nvSpPr>
+          <p:cNvPr id="9" name="TextBox 8"/>
+          <p:cNvSpPr txBox="1"/>
+          <p:nvPr/>
+        </p:nvSpPr>
+        <p:spPr>
+          <a:xfrm>
+            <a:off x="9509760" y="6473952"/>
+            <a:ext cx="2103120" cy="274320"/>
           </a:xfrm>
           <a:prstGeom prst="rect">
             <a:avLst/>
@@ -10242,7 +11350,7 @@
           <a:lstStyle/>
           <a:p>
             <a:pPr algn="r">
-              <a:defRPr sz="1400" b="0">
+              <a:defRPr sz="1200" b="0">
                 <a:solidFill>
                   <a:srgbClr val="45464D"/>
                 </a:solidFill>
@@ -10250,7 +11358,133 @@
               </a:defRPr>
             </a:pPr>
             <a:r>
-              <a:t>6 / 12</a:t>
+              <a:t>Pitch Deck v3   ·   6 / 12</a:t>
+            </a:r>
+          </a:p>
+        </p:txBody>
+      </p:sp>
+      <p:sp>
+        <p:nvSpPr>
+          <p:cNvPr id="10" name="Rounded Rectangle 9"/>
+          <p:cNvSpPr/>
+          <p:nvPr/>
+        </p:nvSpPr>
+        <p:spPr>
+          <a:xfrm>
+            <a:off x="8915400" y="502920"/>
+            <a:ext cx="2514600" cy="329184"/>
+          </a:xfrm>
+          <a:prstGeom prst="roundRect">
+            <a:avLst>
+              <a:gd name="adj" fmla="val 50000"/>
+            </a:avLst>
+          </a:prstGeom>
+          <a:solidFill>
+            <a:srgbClr val="EFF4FF"/>
+          </a:solidFill>
+          <a:ln w="12700">
+            <a:solidFill>
+              <a:srgbClr val="E2E8F0"/>
+            </a:solidFill>
+          </a:ln>
+        </p:spPr>
+        <p:style>
+          <a:lnRef idx="1">
+            <a:schemeClr val="accent1"/>
+          </a:lnRef>
+          <a:fillRef idx="3">
+            <a:schemeClr val="accent1"/>
+          </a:fillRef>
+          <a:effectRef idx="2">
+            <a:schemeClr val="accent1"/>
+          </a:effectRef>
+          <a:fontRef idx="minor">
+            <a:schemeClr val="lt1"/>
+          </a:fontRef>
+        </p:style>
+        <p:txBody>
+          <a:bodyPr rtlCol="0" anchor="ctr"/>
+          <a:lstStyle/>
+          <a:p>
+            <a:pPr algn="ctr"/>
+          </a:p>
+        </p:txBody>
+      </p:sp>
+      <p:sp>
+        <p:nvSpPr>
+          <p:cNvPr id="11" name="Oval 10"/>
+          <p:cNvSpPr/>
+          <p:nvPr/>
+        </p:nvSpPr>
+        <p:spPr>
+          <a:xfrm>
+            <a:off x="9116568" y="621792"/>
+            <a:ext cx="100584" cy="100584"/>
+          </a:xfrm>
+          <a:prstGeom prst="ellipse">
+            <a:avLst/>
+          </a:prstGeom>
+          <a:solidFill>
+            <a:srgbClr val="009668"/>
+          </a:solidFill>
+          <a:ln>
+            <a:noFill/>
+          </a:ln>
+        </p:spPr>
+        <p:style>
+          <a:lnRef idx="1">
+            <a:schemeClr val="accent1"/>
+          </a:lnRef>
+          <a:fillRef idx="3">
+            <a:schemeClr val="accent1"/>
+          </a:fillRef>
+          <a:effectRef idx="2">
+            <a:schemeClr val="accent1"/>
+          </a:effectRef>
+          <a:fontRef idx="minor">
+            <a:schemeClr val="lt1"/>
+          </a:fontRef>
+        </p:style>
+        <p:txBody>
+          <a:bodyPr rtlCol="0" anchor="ctr"/>
+          <a:lstStyle/>
+          <a:p>
+            <a:pPr algn="ctr"/>
+          </a:p>
+        </p:txBody>
+      </p:sp>
+      <p:sp>
+        <p:nvSpPr>
+          <p:cNvPr id="12" name="TextBox 11"/>
+          <p:cNvSpPr txBox="1"/>
+          <p:nvPr/>
+        </p:nvSpPr>
+        <p:spPr>
+          <a:xfrm>
+            <a:off x="9299448" y="548640"/>
+            <a:ext cx="2057400" cy="256032"/>
+          </a:xfrm>
+          <a:prstGeom prst="rect">
+            <a:avLst/>
+          </a:prstGeom>
+          <a:noFill/>
+        </p:spPr>
+        <p:txBody>
+          <a:bodyPr wrap="square">
+            <a:spAutoFit/>
+          </a:bodyPr>
+          <a:lstStyle/>
+          <a:p>
+            <a:pPr algn="l">
+              <a:defRPr sz="1200" b="1">
+                <a:solidFill>
+                  <a:srgbClr val="006A61"/>
+                </a:solidFill>
+                <a:latin typeface="SF Pro Display"/>
+              </a:defRPr>
+            </a:pPr>
+            <a:r>
+              <a:t>Blockchain Status: Secured</a:t>
             </a:r>
           </a:p>
         </p:txBody>
@@ -10366,7 +11600,7 @@
           </a:xfrm>
           <a:prstGeom prst="roundRect">
             <a:avLst>
-              <a:gd name="adj" fmla="val 8000"/>
+              <a:gd name="adj" fmla="val 10000"/>
             </a:avLst>
           </a:prstGeom>
           <a:solidFill>
@@ -10377,6 +11611,13 @@
               <a:srgbClr val="E2E8F0"/>
             </a:solidFill>
           </a:ln>
+          <a:effectLst>
+            <a:outerShdw blurRad="76200" dist="34925" dir="5400000" rotWithShape="0">
+              <a:srgbClr val="0F172A">
+                <a:alpha val="14000"/>
+              </a:srgbClr>
+            </a:outerShdw>
+          </a:effectLst>
         </p:spPr>
         <p:style>
           <a:lnRef idx="1">
@@ -10485,7 +11726,7 @@
           </a:xfrm>
           <a:prstGeom prst="roundRect">
             <a:avLst>
-              <a:gd name="adj" fmla="val 8000"/>
+              <a:gd name="adj" fmla="val 10000"/>
             </a:avLst>
           </a:prstGeom>
           <a:solidFill>
@@ -10496,6 +11737,13 @@
               <a:srgbClr val="E2E8F0"/>
             </a:solidFill>
           </a:ln>
+          <a:effectLst>
+            <a:outerShdw blurRad="76200" dist="34925" dir="5400000" rotWithShape="0">
+              <a:srgbClr val="0F172A">
+                <a:alpha val="14000"/>
+              </a:srgbClr>
+            </a:outerShdw>
+          </a:effectLst>
         </p:spPr>
         <p:style>
           <a:lnRef idx="1">
@@ -10604,7 +11852,7 @@
           </a:xfrm>
           <a:prstGeom prst="roundRect">
             <a:avLst>
-              <a:gd name="adj" fmla="val 8000"/>
+              <a:gd name="adj" fmla="val 10000"/>
             </a:avLst>
           </a:prstGeom>
           <a:solidFill>
@@ -10615,6 +11863,13 @@
               <a:srgbClr val="E2E8F0"/>
             </a:solidFill>
           </a:ln>
+          <a:effectLst>
+            <a:outerShdw blurRad="76200" dist="34925" dir="5400000" rotWithShape="0">
+              <a:srgbClr val="0F172A">
+                <a:alpha val="14000"/>
+              </a:srgbClr>
+            </a:outerShdw>
+          </a:effectLst>
         </p:spPr>
         <p:style>
           <a:lnRef idx="1">
@@ -10723,7 +11978,7 @@
           </a:xfrm>
           <a:prstGeom prst="roundRect">
             <a:avLst>
-              <a:gd name="adj" fmla="val 8000"/>
+              <a:gd name="adj" fmla="val 10000"/>
             </a:avLst>
           </a:prstGeom>
           <a:solidFill>
@@ -10734,6 +11989,13 @@
               <a:srgbClr val="E2E8F0"/>
             </a:solidFill>
           </a:ln>
+          <a:effectLst>
+            <a:outerShdw blurRad="76200" dist="34925" dir="5400000" rotWithShape="0">
+              <a:srgbClr val="0F172A">
+                <a:alpha val="14000"/>
+              </a:srgbClr>
+            </a:outerShdw>
+          </a:effectLst>
         </p:spPr>
         <p:style>
           <a:lnRef idx="1">
@@ -10904,8 +12166,8 @@
         </p:nvSpPr>
         <p:spPr>
           <a:xfrm>
-            <a:off x="960120" y="6446520"/>
-            <a:ext cx="2743200" cy="274320"/>
+            <a:off x="960120" y="6419088"/>
+            <a:ext cx="2926080" cy="274320"/>
           </a:xfrm>
           <a:prstGeom prst="rect">
             <a:avLst/>
@@ -10927,7 +12189,7 @@
               </a:defRPr>
             </a:pPr>
             <a:r>
-              <a:t>Krunchr · Pitch Deck v3</a:t>
+              <a:t>Krunchr</a:t>
             </a:r>
           </a:p>
         </p:txBody>
@@ -10940,8 +12202,44 @@
         </p:nvSpPr>
         <p:spPr>
           <a:xfrm>
-            <a:off x="10607040" y="6446520"/>
-            <a:ext cx="1005840" cy="274320"/>
+            <a:off x="960120" y="6647688"/>
+            <a:ext cx="2926080" cy="201168"/>
+          </a:xfrm>
+          <a:prstGeom prst="rect">
+            <a:avLst/>
+          </a:prstGeom>
+          <a:noFill/>
+        </p:spPr>
+        <p:txBody>
+          <a:bodyPr wrap="square">
+            <a:spAutoFit/>
+          </a:bodyPr>
+          <a:lstStyle/>
+          <a:p>
+            <a:pPr algn="l">
+              <a:defRPr sz="900" b="0">
+                <a:solidFill>
+                  <a:srgbClr val="45464D"/>
+                </a:solidFill>
+                <a:latin typeface="SF Pro Display"/>
+              </a:defRPr>
+            </a:pPr>
+            <a:r>
+              <a:t>Compliance Engine</a:t>
+            </a:r>
+          </a:p>
+        </p:txBody>
+      </p:sp>
+      <p:sp>
+        <p:nvSpPr>
+          <p:cNvPr id="20" name="TextBox 19"/>
+          <p:cNvSpPr txBox="1"/>
+          <p:nvPr/>
+        </p:nvSpPr>
+        <p:spPr>
+          <a:xfrm>
+            <a:off x="9509760" y="6473952"/>
+            <a:ext cx="2103120" cy="274320"/>
           </a:xfrm>
           <a:prstGeom prst="rect">
             <a:avLst/>
@@ -10955,7 +12253,7 @@
           <a:lstStyle/>
           <a:p>
             <a:pPr algn="r">
-              <a:defRPr sz="1400" b="0">
+              <a:defRPr sz="1200" b="0">
                 <a:solidFill>
                   <a:srgbClr val="45464D"/>
                 </a:solidFill>
@@ -10963,7 +12261,133 @@
               </a:defRPr>
             </a:pPr>
             <a:r>
-              <a:t>7 / 12</a:t>
+              <a:t>Pitch Deck v3   ·   7 / 12</a:t>
+            </a:r>
+          </a:p>
+        </p:txBody>
+      </p:sp>
+      <p:sp>
+        <p:nvSpPr>
+          <p:cNvPr id="21" name="Rounded Rectangle 20"/>
+          <p:cNvSpPr/>
+          <p:nvPr/>
+        </p:nvSpPr>
+        <p:spPr>
+          <a:xfrm>
+            <a:off x="8915400" y="502920"/>
+            <a:ext cx="2514600" cy="329184"/>
+          </a:xfrm>
+          <a:prstGeom prst="roundRect">
+            <a:avLst>
+              <a:gd name="adj" fmla="val 50000"/>
+            </a:avLst>
+          </a:prstGeom>
+          <a:solidFill>
+            <a:srgbClr val="EFF4FF"/>
+          </a:solidFill>
+          <a:ln w="12700">
+            <a:solidFill>
+              <a:srgbClr val="E2E8F0"/>
+            </a:solidFill>
+          </a:ln>
+        </p:spPr>
+        <p:style>
+          <a:lnRef idx="1">
+            <a:schemeClr val="accent1"/>
+          </a:lnRef>
+          <a:fillRef idx="3">
+            <a:schemeClr val="accent1"/>
+          </a:fillRef>
+          <a:effectRef idx="2">
+            <a:schemeClr val="accent1"/>
+          </a:effectRef>
+          <a:fontRef idx="minor">
+            <a:schemeClr val="lt1"/>
+          </a:fontRef>
+        </p:style>
+        <p:txBody>
+          <a:bodyPr rtlCol="0" anchor="ctr"/>
+          <a:lstStyle/>
+          <a:p>
+            <a:pPr algn="ctr"/>
+          </a:p>
+        </p:txBody>
+      </p:sp>
+      <p:sp>
+        <p:nvSpPr>
+          <p:cNvPr id="22" name="Oval 21"/>
+          <p:cNvSpPr/>
+          <p:nvPr/>
+        </p:nvSpPr>
+        <p:spPr>
+          <a:xfrm>
+            <a:off x="9116568" y="621792"/>
+            <a:ext cx="100584" cy="100584"/>
+          </a:xfrm>
+          <a:prstGeom prst="ellipse">
+            <a:avLst/>
+          </a:prstGeom>
+          <a:solidFill>
+            <a:srgbClr val="009668"/>
+          </a:solidFill>
+          <a:ln>
+            <a:noFill/>
+          </a:ln>
+        </p:spPr>
+        <p:style>
+          <a:lnRef idx="1">
+            <a:schemeClr val="accent1"/>
+          </a:lnRef>
+          <a:fillRef idx="3">
+            <a:schemeClr val="accent1"/>
+          </a:fillRef>
+          <a:effectRef idx="2">
+            <a:schemeClr val="accent1"/>
+          </a:effectRef>
+          <a:fontRef idx="minor">
+            <a:schemeClr val="lt1"/>
+          </a:fontRef>
+        </p:style>
+        <p:txBody>
+          <a:bodyPr rtlCol="0" anchor="ctr"/>
+          <a:lstStyle/>
+          <a:p>
+            <a:pPr algn="ctr"/>
+          </a:p>
+        </p:txBody>
+      </p:sp>
+      <p:sp>
+        <p:nvSpPr>
+          <p:cNvPr id="23" name="TextBox 22"/>
+          <p:cNvSpPr txBox="1"/>
+          <p:nvPr/>
+        </p:nvSpPr>
+        <p:spPr>
+          <a:xfrm>
+            <a:off x="9299448" y="548640"/>
+            <a:ext cx="2057400" cy="256032"/>
+          </a:xfrm>
+          <a:prstGeom prst="rect">
+            <a:avLst/>
+          </a:prstGeom>
+          <a:noFill/>
+        </p:spPr>
+        <p:txBody>
+          <a:bodyPr wrap="square">
+            <a:spAutoFit/>
+          </a:bodyPr>
+          <a:lstStyle/>
+          <a:p>
+            <a:pPr algn="l">
+              <a:defRPr sz="1200" b="1">
+                <a:solidFill>
+                  <a:srgbClr val="006A61"/>
+                </a:solidFill>
+                <a:latin typeface="SF Pro Display"/>
+              </a:defRPr>
+            </a:pPr>
+            <a:r>
+              <a:t>Blockchain Status: Secured</a:t>
             </a:r>
           </a:p>
         </p:txBody>
@@ -11115,7 +12539,7 @@
           </a:xfrm>
           <a:prstGeom prst="roundRect">
             <a:avLst>
-              <a:gd name="adj" fmla="val 8000"/>
+              <a:gd name="adj" fmla="val 10000"/>
             </a:avLst>
           </a:prstGeom>
           <a:solidFill>
@@ -11126,6 +12550,13 @@
               <a:srgbClr val="E2E8F0"/>
             </a:solidFill>
           </a:ln>
+          <a:effectLst>
+            <a:outerShdw blurRad="76200" dist="34925" dir="5400000" rotWithShape="0">
+              <a:srgbClr val="0F172A">
+                <a:alpha val="14000"/>
+              </a:srgbClr>
+            </a:outerShdw>
+          </a:effectLst>
         </p:spPr>
         <p:style>
           <a:lnRef idx="1">
@@ -11313,7 +12744,7 @@
           </a:xfrm>
           <a:prstGeom prst="roundRect">
             <a:avLst>
-              <a:gd name="adj" fmla="val 8000"/>
+              <a:gd name="adj" fmla="val 10000"/>
             </a:avLst>
           </a:prstGeom>
           <a:solidFill>
@@ -11324,6 +12755,13 @@
               <a:srgbClr val="E2E8F0"/>
             </a:solidFill>
           </a:ln>
+          <a:effectLst>
+            <a:outerShdw blurRad="76200" dist="34925" dir="5400000" rotWithShape="0">
+              <a:srgbClr val="0F172A">
+                <a:alpha val="14000"/>
+              </a:srgbClr>
+            </a:outerShdw>
+          </a:effectLst>
         </p:spPr>
         <p:style>
           <a:lnRef idx="1">
@@ -11511,7 +12949,7 @@
           </a:xfrm>
           <a:prstGeom prst="roundRect">
             <a:avLst>
-              <a:gd name="adj" fmla="val 8000"/>
+              <a:gd name="adj" fmla="val 10000"/>
             </a:avLst>
           </a:prstGeom>
           <a:solidFill>
@@ -11522,6 +12960,13 @@
               <a:srgbClr val="E2E8F0"/>
             </a:solidFill>
           </a:ln>
+          <a:effectLst>
+            <a:outerShdw blurRad="76200" dist="34925" dir="5400000" rotWithShape="0">
+              <a:srgbClr val="0F172A">
+                <a:alpha val="14000"/>
+              </a:srgbClr>
+            </a:outerShdw>
+          </a:effectLst>
         </p:spPr>
         <p:style>
           <a:lnRef idx="1">
@@ -11771,8 +13216,8 @@
         </p:nvSpPr>
         <p:spPr>
           <a:xfrm>
-            <a:off x="960120" y="6446520"/>
-            <a:ext cx="2743200" cy="274320"/>
+            <a:off x="960120" y="6419088"/>
+            <a:ext cx="2926080" cy="274320"/>
           </a:xfrm>
           <a:prstGeom prst="rect">
             <a:avLst/>
@@ -11794,7 +13239,7 @@
               </a:defRPr>
             </a:pPr>
             <a:r>
-              <a:t>Krunchr · Pitch Deck v3</a:t>
+              <a:t>Krunchr</a:t>
             </a:r>
           </a:p>
         </p:txBody>
@@ -11807,8 +13252,44 @@
         </p:nvSpPr>
         <p:spPr>
           <a:xfrm>
-            <a:off x="10607040" y="6446520"/>
-            <a:ext cx="1005840" cy="274320"/>
+            <a:off x="960120" y="6647688"/>
+            <a:ext cx="2926080" cy="201168"/>
+          </a:xfrm>
+          <a:prstGeom prst="rect">
+            <a:avLst/>
+          </a:prstGeom>
+          <a:noFill/>
+        </p:spPr>
+        <p:txBody>
+          <a:bodyPr wrap="square">
+            <a:spAutoFit/>
+          </a:bodyPr>
+          <a:lstStyle/>
+          <a:p>
+            <a:pPr algn="l">
+              <a:defRPr sz="900" b="0">
+                <a:solidFill>
+                  <a:srgbClr val="45464D"/>
+                </a:solidFill>
+                <a:latin typeface="SF Pro Display"/>
+              </a:defRPr>
+            </a:pPr>
+            <a:r>
+              <a:t>Compliance Engine</a:t>
+            </a:r>
+          </a:p>
+        </p:txBody>
+      </p:sp>
+      <p:sp>
+        <p:nvSpPr>
+          <p:cNvPr id="24" name="TextBox 23"/>
+          <p:cNvSpPr txBox="1"/>
+          <p:nvPr/>
+        </p:nvSpPr>
+        <p:spPr>
+          <a:xfrm>
+            <a:off x="9509760" y="6473952"/>
+            <a:ext cx="2103120" cy="274320"/>
           </a:xfrm>
           <a:prstGeom prst="rect">
             <a:avLst/>
@@ -11822,7 +13303,7 @@
           <a:lstStyle/>
           <a:p>
             <a:pPr algn="r">
-              <a:defRPr sz="1400" b="0">
+              <a:defRPr sz="1200" b="0">
                 <a:solidFill>
                   <a:srgbClr val="45464D"/>
                 </a:solidFill>
@@ -11830,7 +13311,133 @@
               </a:defRPr>
             </a:pPr>
             <a:r>
-              <a:t>8 / 12</a:t>
+              <a:t>Pitch Deck v3   ·   8 / 12</a:t>
+            </a:r>
+          </a:p>
+        </p:txBody>
+      </p:sp>
+      <p:sp>
+        <p:nvSpPr>
+          <p:cNvPr id="25" name="Rounded Rectangle 24"/>
+          <p:cNvSpPr/>
+          <p:nvPr/>
+        </p:nvSpPr>
+        <p:spPr>
+          <a:xfrm>
+            <a:off x="8915400" y="502920"/>
+            <a:ext cx="2514600" cy="329184"/>
+          </a:xfrm>
+          <a:prstGeom prst="roundRect">
+            <a:avLst>
+              <a:gd name="adj" fmla="val 50000"/>
+            </a:avLst>
+          </a:prstGeom>
+          <a:solidFill>
+            <a:srgbClr val="EFF4FF"/>
+          </a:solidFill>
+          <a:ln w="12700">
+            <a:solidFill>
+              <a:srgbClr val="E2E8F0"/>
+            </a:solidFill>
+          </a:ln>
+        </p:spPr>
+        <p:style>
+          <a:lnRef idx="1">
+            <a:schemeClr val="accent1"/>
+          </a:lnRef>
+          <a:fillRef idx="3">
+            <a:schemeClr val="accent1"/>
+          </a:fillRef>
+          <a:effectRef idx="2">
+            <a:schemeClr val="accent1"/>
+          </a:effectRef>
+          <a:fontRef idx="minor">
+            <a:schemeClr val="lt1"/>
+          </a:fontRef>
+        </p:style>
+        <p:txBody>
+          <a:bodyPr rtlCol="0" anchor="ctr"/>
+          <a:lstStyle/>
+          <a:p>
+            <a:pPr algn="ctr"/>
+          </a:p>
+        </p:txBody>
+      </p:sp>
+      <p:sp>
+        <p:nvSpPr>
+          <p:cNvPr id="26" name="Oval 25"/>
+          <p:cNvSpPr/>
+          <p:nvPr/>
+        </p:nvSpPr>
+        <p:spPr>
+          <a:xfrm>
+            <a:off x="9116568" y="621792"/>
+            <a:ext cx="100584" cy="100584"/>
+          </a:xfrm>
+          <a:prstGeom prst="ellipse">
+            <a:avLst/>
+          </a:prstGeom>
+          <a:solidFill>
+            <a:srgbClr val="009668"/>
+          </a:solidFill>
+          <a:ln>
+            <a:noFill/>
+          </a:ln>
+        </p:spPr>
+        <p:style>
+          <a:lnRef idx="1">
+            <a:schemeClr val="accent1"/>
+          </a:lnRef>
+          <a:fillRef idx="3">
+            <a:schemeClr val="accent1"/>
+          </a:fillRef>
+          <a:effectRef idx="2">
+            <a:schemeClr val="accent1"/>
+          </a:effectRef>
+          <a:fontRef idx="minor">
+            <a:schemeClr val="lt1"/>
+          </a:fontRef>
+        </p:style>
+        <p:txBody>
+          <a:bodyPr rtlCol="0" anchor="ctr"/>
+          <a:lstStyle/>
+          <a:p>
+            <a:pPr algn="ctr"/>
+          </a:p>
+        </p:txBody>
+      </p:sp>
+      <p:sp>
+        <p:nvSpPr>
+          <p:cNvPr id="27" name="TextBox 26"/>
+          <p:cNvSpPr txBox="1"/>
+          <p:nvPr/>
+        </p:nvSpPr>
+        <p:spPr>
+          <a:xfrm>
+            <a:off x="9299448" y="548640"/>
+            <a:ext cx="2057400" cy="256032"/>
+          </a:xfrm>
+          <a:prstGeom prst="rect">
+            <a:avLst/>
+          </a:prstGeom>
+          <a:noFill/>
+        </p:spPr>
+        <p:txBody>
+          <a:bodyPr wrap="square">
+            <a:spAutoFit/>
+          </a:bodyPr>
+          <a:lstStyle/>
+          <a:p>
+            <a:pPr algn="l">
+              <a:defRPr sz="1200" b="1">
+                <a:solidFill>
+                  <a:srgbClr val="006A61"/>
+                </a:solidFill>
+                <a:latin typeface="SF Pro Display"/>
+              </a:defRPr>
+            </a:pPr>
+            <a:r>
+              <a:t>Blockchain Status: Secured</a:t>
             </a:r>
           </a:p>
         </p:txBody>
@@ -12197,8 +13804,8 @@
         </p:nvSpPr>
         <p:spPr>
           <a:xfrm>
-            <a:off x="960120" y="6446520"/>
-            <a:ext cx="2743200" cy="274320"/>
+            <a:off x="960120" y="6419088"/>
+            <a:ext cx="2926080" cy="274320"/>
           </a:xfrm>
           <a:prstGeom prst="rect">
             <a:avLst/>
@@ -12220,7 +13827,7 @@
               </a:defRPr>
             </a:pPr>
             <a:r>
-              <a:t>Krunchr · Pitch Deck v3</a:t>
+              <a:t>Krunchr</a:t>
             </a:r>
           </a:p>
         </p:txBody>
@@ -12233,8 +13840,44 @@
         </p:nvSpPr>
         <p:spPr>
           <a:xfrm>
-            <a:off x="10607040" y="6446520"/>
-            <a:ext cx="1005840" cy="274320"/>
+            <a:off x="960120" y="6647688"/>
+            <a:ext cx="2926080" cy="201168"/>
+          </a:xfrm>
+          <a:prstGeom prst="rect">
+            <a:avLst/>
+          </a:prstGeom>
+          <a:noFill/>
+        </p:spPr>
+        <p:txBody>
+          <a:bodyPr wrap="square">
+            <a:spAutoFit/>
+          </a:bodyPr>
+          <a:lstStyle/>
+          <a:p>
+            <a:pPr algn="l">
+              <a:defRPr sz="900" b="0">
+                <a:solidFill>
+                  <a:srgbClr val="45464D"/>
+                </a:solidFill>
+                <a:latin typeface="SF Pro Display"/>
+              </a:defRPr>
+            </a:pPr>
+            <a:r>
+              <a:t>Compliance Engine</a:t>
+            </a:r>
+          </a:p>
+        </p:txBody>
+      </p:sp>
+      <p:sp>
+        <p:nvSpPr>
+          <p:cNvPr id="11" name="TextBox 10"/>
+          <p:cNvSpPr txBox="1"/>
+          <p:nvPr/>
+        </p:nvSpPr>
+        <p:spPr>
+          <a:xfrm>
+            <a:off x="9509760" y="6473952"/>
+            <a:ext cx="2103120" cy="274320"/>
           </a:xfrm>
           <a:prstGeom prst="rect">
             <a:avLst/>
@@ -12248,7 +13891,7 @@
           <a:lstStyle/>
           <a:p>
             <a:pPr algn="r">
-              <a:defRPr sz="1400" b="0">
+              <a:defRPr sz="1200" b="0">
                 <a:solidFill>
                   <a:srgbClr val="45464D"/>
                 </a:solidFill>
@@ -12256,7 +13899,7 @@
               </a:defRPr>
             </a:pPr>
             <a:r>
-              <a:t>9 / 12</a:t>
+              <a:t>Pitch Deck v3   ·   9 / 12</a:t>
             </a:r>
           </a:p>
         </p:txBody>

</xml_diff>